<commit_message>
Fit EPRSTMT appendix title inside its editable text frame
</commit_message>
<xml_diff>
--- a/slides/datasets-in-10-minutes-eprstmt.pptx
+++ b/slides/datasets-in-10-minutes-eprstmt.pptx
@@ -13614,11 +13614,11 @@
         <p:spPr>
           <a:xfrm>
             <a:off x="548640" y="2484835"/>
-            <a:ext cx="8046720" cy="585216"/>
-          </a:xfrm>
-        </p:spPr>
-        <p:txBody>
-          <a:bodyPr wrap="square" lIns="0" rIns="0" tIns="0" bIns="0" anchor="ctr">
+            <a:ext cx="8046720" cy="686816"/>
+          </a:xfrm>
+        </p:spPr>
+        <p:txBody>
+          <a:bodyPr wrap="square" lIns="0" rIns="0" tIns="0" bIns="101600" anchor="ctr">
             <a:noAutofit/>
           </a:bodyPr>
           <a:lstStyle/>

</xml_diff>